<commit_message>
Update PowerPoint for song #95 in FUBC - Українські
</commit_message>
<xml_diff>
--- a/fubc-ua/95-Боже слави і спасіння (Пісні Спасенних №90).pptx
+++ b/fubc-ua/95-Боже слави і спасіння (Пісні Спасенних №90).pptx
@@ -595,7 +595,7 @@
           <a:p>
             <a:r>
               <a:rPr lang="en-US" dirty="0"/>
-              <a:t>1 · 1/1</a:t>
+              <a:t>1 · 1/1 · ||:6-6:||</a:t>
             </a:r>
             <a:endParaRPr lang="en-US" dirty="0"/>
           </a:p>
@@ -683,7 +683,7 @@
           <a:p>
             <a:r>
               <a:rPr lang="en-US" dirty="0"/>
-              <a:t>2 · 1/1</a:t>
+              <a:t>2 · 1/1 · ||:6-6:||</a:t>
             </a:r>
             <a:endParaRPr lang="en-US" dirty="0"/>
           </a:p>
@@ -771,7 +771,7 @@
           <a:p>
             <a:r>
               <a:rPr lang="en-US" dirty="0"/>
-              <a:t>3 · 1/1</a:t>
+              <a:t>3 · 1/1 · ||:6-6:||</a:t>
             </a:r>
             <a:endParaRPr lang="en-US" dirty="0"/>
           </a:p>
@@ -859,7 +859,7 @@
           <a:p>
             <a:r>
               <a:rPr lang="en-US" dirty="0"/>
-              <a:t>4 · 1/1</a:t>
+              <a:t>4 · 1/1 · ||:6-6:||</a:t>
             </a:r>
             <a:endParaRPr lang="en-US" dirty="0"/>
           </a:p>
@@ -1430,6 +1430,9 @@
           <a:lstStyle/>
           <a:p>
             <a:pPr algn="ctr" indent="0" marL="0">
+              <a:lnSpc>
+                <a:spcPts val="6200"/>
+              </a:lnSpc>
               <a:buNone/>
             </a:pPr>
             <a:r>
@@ -1447,6 +1450,9 @@
           </a:p>
           <a:p>
             <a:pPr algn="ctr" indent="0" marL="0">
+              <a:lnSpc>
+                <a:spcPts val="6200"/>
+              </a:lnSpc>
               <a:buNone/>
             </a:pPr>
             <a:r>
@@ -1464,6 +1470,9 @@
           </a:p>
           <a:p>
             <a:pPr algn="ctr" indent="0" marL="0">
+              <a:lnSpc>
+                <a:spcPts val="6200"/>
+              </a:lnSpc>
               <a:buNone/>
             </a:pPr>
             <a:r>
@@ -1481,6 +1490,9 @@
           </a:p>
           <a:p>
             <a:pPr algn="ctr" indent="0" marL="0">
+              <a:lnSpc>
+                <a:spcPts val="6200"/>
+              </a:lnSpc>
               <a:buNone/>
             </a:pPr>
             <a:r>
@@ -1498,6 +1510,9 @@
           </a:p>
           <a:p>
             <a:pPr algn="ctr" indent="0" marL="0">
+              <a:lnSpc>
+                <a:spcPts val="6200"/>
+              </a:lnSpc>
               <a:buNone/>
             </a:pPr>
             <a:r>
@@ -1515,6 +1530,9 @@
           </a:p>
           <a:p>
             <a:pPr algn="ctr" indent="0" marL="0">
+              <a:lnSpc>
+                <a:spcPts val="6200"/>
+              </a:lnSpc>
               <a:buNone/>
             </a:pPr>
             <a:r>
@@ -1526,9 +1544,94 @@
                 <a:ea typeface="Arial" pitchFamily="34" charset="-122"/>
                 <a:cs typeface="Arial" pitchFamily="34" charset="-120"/>
               </a:rPr>
-              <a:t>||: Слово сповнити святе. :||</a:t>
+              <a:t>Слово сповнити святе.</a:t>
             </a:r>
             <a:endParaRPr lang="en-US" sz="5200" dirty="0"/>
+          </a:p>
+        </p:txBody>
+      </p:sp>
+      <p:sp>
+        <p:nvSpPr>
+          <p:cNvPr id="3" name="Shape 1"/>
+          <p:cNvSpPr/>
+          <p:nvPr/>
+        </p:nvSpPr>
+        <p:spPr>
+          <a:xfrm>
+            <a:off x="2058060" y="5132832"/>
+            <a:ext cx="0" cy="594360"/>
+          </a:xfrm>
+          <a:prstGeom prst="line">
+            <a:avLst/>
+          </a:prstGeom>
+          <a:noFill/>
+          <a:ln w="25400">
+            <a:solidFill>
+              <a:srgbClr val="8A8A8A"/>
+            </a:solidFill>
+            <a:prstDash val="solid"/>
+          </a:ln>
+        </p:spPr>
+      </p:sp>
+      <p:sp>
+        <p:nvSpPr>
+          <p:cNvPr id="4" name="Shape 2"/>
+          <p:cNvSpPr/>
+          <p:nvPr/>
+        </p:nvSpPr>
+        <p:spPr>
+          <a:xfrm>
+            <a:off x="10140036" y="5132832"/>
+            <a:ext cx="0" cy="594360"/>
+          </a:xfrm>
+          <a:prstGeom prst="line">
+            <a:avLst/>
+          </a:prstGeom>
+          <a:noFill/>
+          <a:ln w="25400">
+            <a:solidFill>
+              <a:srgbClr val="8A8A8A"/>
+            </a:solidFill>
+            <a:prstDash val="solid"/>
+          </a:ln>
+        </p:spPr>
+      </p:sp>
+      <p:sp>
+        <p:nvSpPr>
+          <p:cNvPr id="5" name="Text 3"/>
+          <p:cNvSpPr txBox="1"/>
+          <p:nvPr/>
+        </p:nvSpPr>
+        <p:spPr>
+          <a:xfrm>
+            <a:off x="10239096" y="5109972"/>
+            <a:ext cx="1097280" cy="640080"/>
+          </a:xfrm>
+          <a:prstGeom prst="rect">
+            <a:avLst/>
+          </a:prstGeom>
+          <a:noFill/>
+          <a:ln/>
+        </p:spPr>
+        <p:txBody>
+          <a:bodyPr wrap="square" lIns="0" tIns="0" rIns="0" bIns="0" rtlCol="0" anchor="ctr"/>
+          <a:lstStyle/>
+          <a:p>
+            <a:pPr algn="l" indent="0" marL="0">
+              <a:buNone/>
+            </a:pPr>
+            <a:r>
+              <a:rPr lang="en-US" sz="3600" b="1" dirty="0">
+                <a:solidFill>
+                  <a:srgbClr val="BBBBBB"/>
+                </a:solidFill>
+                <a:latin typeface="Arial" pitchFamily="34" charset="0"/>
+                <a:ea typeface="Arial" pitchFamily="34" charset="-122"/>
+                <a:cs typeface="Arial" pitchFamily="34" charset="-120"/>
+              </a:rPr>
+              <a:t>×2</a:t>
+            </a:r>
+            <a:endParaRPr lang="en-US" sz="3600" dirty="0"/>
           </a:p>
         </p:txBody>
       </p:sp>
@@ -1586,6 +1689,9 @@
           <a:lstStyle/>
           <a:p>
             <a:pPr algn="ctr" indent="0" marL="0">
+              <a:lnSpc>
+                <a:spcPts val="6200"/>
+              </a:lnSpc>
               <a:buNone/>
             </a:pPr>
             <a:r>
@@ -1603,6 +1709,9 @@
           </a:p>
           <a:p>
             <a:pPr algn="ctr" indent="0" marL="0">
+              <a:lnSpc>
+                <a:spcPts val="6200"/>
+              </a:lnSpc>
               <a:buNone/>
             </a:pPr>
             <a:r>
@@ -1620,6 +1729,9 @@
           </a:p>
           <a:p>
             <a:pPr algn="ctr" indent="0" marL="0">
+              <a:lnSpc>
+                <a:spcPts val="6200"/>
+              </a:lnSpc>
               <a:buNone/>
             </a:pPr>
             <a:r>
@@ -1637,6 +1749,9 @@
           </a:p>
           <a:p>
             <a:pPr algn="ctr" indent="0" marL="0">
+              <a:lnSpc>
+                <a:spcPts val="6200"/>
+              </a:lnSpc>
               <a:buNone/>
             </a:pPr>
             <a:r>
@@ -1654,6 +1769,9 @@
           </a:p>
           <a:p>
             <a:pPr algn="ctr" indent="0" marL="0">
+              <a:lnSpc>
+                <a:spcPts val="6200"/>
+              </a:lnSpc>
               <a:buNone/>
             </a:pPr>
             <a:r>
@@ -1671,6 +1789,9 @@
           </a:p>
           <a:p>
             <a:pPr algn="ctr" indent="0" marL="0">
+              <a:lnSpc>
+                <a:spcPts val="6200"/>
+              </a:lnSpc>
               <a:buNone/>
             </a:pPr>
             <a:r>
@@ -1682,9 +1803,94 @@
                 <a:ea typeface="Arial" pitchFamily="34" charset="-122"/>
                 <a:cs typeface="Arial" pitchFamily="34" charset="-120"/>
               </a:rPr>
-              <a:t>||: встояти щоб до кінця. :||</a:t>
+              <a:t>встояти щоб до кінця.</a:t>
             </a:r>
             <a:endParaRPr lang="en-US" sz="5200" dirty="0"/>
+          </a:p>
+        </p:txBody>
+      </p:sp>
+      <p:sp>
+        <p:nvSpPr>
+          <p:cNvPr id="3" name="Shape 1"/>
+          <p:cNvSpPr/>
+          <p:nvPr/>
+        </p:nvSpPr>
+        <p:spPr>
+          <a:xfrm>
+            <a:off x="2245284" y="5132832"/>
+            <a:ext cx="0" cy="594360"/>
+          </a:xfrm>
+          <a:prstGeom prst="line">
+            <a:avLst/>
+          </a:prstGeom>
+          <a:noFill/>
+          <a:ln w="25400">
+            <a:solidFill>
+              <a:srgbClr val="8A8A8A"/>
+            </a:solidFill>
+            <a:prstDash val="solid"/>
+          </a:ln>
+        </p:spPr>
+      </p:sp>
+      <p:sp>
+        <p:nvSpPr>
+          <p:cNvPr id="4" name="Shape 2"/>
+          <p:cNvSpPr/>
+          <p:nvPr/>
+        </p:nvSpPr>
+        <p:spPr>
+          <a:xfrm>
+            <a:off x="9952812" y="5132832"/>
+            <a:ext cx="0" cy="594360"/>
+          </a:xfrm>
+          <a:prstGeom prst="line">
+            <a:avLst/>
+          </a:prstGeom>
+          <a:noFill/>
+          <a:ln w="25400">
+            <a:solidFill>
+              <a:srgbClr val="8A8A8A"/>
+            </a:solidFill>
+            <a:prstDash val="solid"/>
+          </a:ln>
+        </p:spPr>
+      </p:sp>
+      <p:sp>
+        <p:nvSpPr>
+          <p:cNvPr id="5" name="Text 3"/>
+          <p:cNvSpPr txBox="1"/>
+          <p:nvPr/>
+        </p:nvSpPr>
+        <p:spPr>
+          <a:xfrm>
+            <a:off x="10051872" y="5109972"/>
+            <a:ext cx="1097280" cy="640080"/>
+          </a:xfrm>
+          <a:prstGeom prst="rect">
+            <a:avLst/>
+          </a:prstGeom>
+          <a:noFill/>
+          <a:ln/>
+        </p:spPr>
+        <p:txBody>
+          <a:bodyPr wrap="square" lIns="0" tIns="0" rIns="0" bIns="0" rtlCol="0" anchor="ctr"/>
+          <a:lstStyle/>
+          <a:p>
+            <a:pPr algn="l" indent="0" marL="0">
+              <a:buNone/>
+            </a:pPr>
+            <a:r>
+              <a:rPr lang="en-US" sz="3600" b="1" dirty="0">
+                <a:solidFill>
+                  <a:srgbClr val="BBBBBB"/>
+                </a:solidFill>
+                <a:latin typeface="Arial" pitchFamily="34" charset="0"/>
+                <a:ea typeface="Arial" pitchFamily="34" charset="-122"/>
+                <a:cs typeface="Arial" pitchFamily="34" charset="-120"/>
+              </a:rPr>
+              <a:t>×2</a:t>
+            </a:r>
+            <a:endParaRPr lang="en-US" sz="3600" dirty="0"/>
           </a:p>
         </p:txBody>
       </p:sp>
@@ -1742,6 +1948,9 @@
           <a:lstStyle/>
           <a:p>
             <a:pPr algn="ctr" indent="0" marL="0">
+              <a:lnSpc>
+                <a:spcPts val="6200"/>
+              </a:lnSpc>
               <a:buNone/>
             </a:pPr>
             <a:r>
@@ -1759,6 +1968,9 @@
           </a:p>
           <a:p>
             <a:pPr algn="ctr" indent="0" marL="0">
+              <a:lnSpc>
+                <a:spcPts val="6200"/>
+              </a:lnSpc>
               <a:buNone/>
             </a:pPr>
             <a:r>
@@ -1776,6 +1988,9 @@
           </a:p>
           <a:p>
             <a:pPr algn="ctr" indent="0" marL="0">
+              <a:lnSpc>
+                <a:spcPts val="6200"/>
+              </a:lnSpc>
               <a:buNone/>
             </a:pPr>
             <a:r>
@@ -1793,6 +2008,9 @@
           </a:p>
           <a:p>
             <a:pPr algn="ctr" indent="0" marL="0">
+              <a:lnSpc>
+                <a:spcPts val="6200"/>
+              </a:lnSpc>
               <a:buNone/>
             </a:pPr>
             <a:r>
@@ -1810,6 +2028,9 @@
           </a:p>
           <a:p>
             <a:pPr algn="ctr" indent="0" marL="0">
+              <a:lnSpc>
+                <a:spcPts val="6200"/>
+              </a:lnSpc>
               <a:buNone/>
             </a:pPr>
             <a:r>
@@ -1827,6 +2048,9 @@
           </a:p>
           <a:p>
             <a:pPr algn="ctr" indent="0" marL="0">
+              <a:lnSpc>
+                <a:spcPts val="6200"/>
+              </a:lnSpc>
               <a:buNone/>
             </a:pPr>
             <a:r>
@@ -1838,9 +2062,94 @@
                 <a:ea typeface="Arial" pitchFamily="34" charset="-122"/>
                 <a:cs typeface="Arial" pitchFamily="34" charset="-120"/>
               </a:rPr>
-              <a:t>||: на путі у світлий рай. :||</a:t>
+              <a:t>на путі у світлий рай.</a:t>
             </a:r>
             <a:endParaRPr lang="en-US" sz="5200" dirty="0"/>
+          </a:p>
+        </p:txBody>
+      </p:sp>
+      <p:sp>
+        <p:nvSpPr>
+          <p:cNvPr id="3" name="Shape 1"/>
+          <p:cNvSpPr/>
+          <p:nvPr/>
+        </p:nvSpPr>
+        <p:spPr>
+          <a:xfrm>
+            <a:off x="2361184" y="5132832"/>
+            <a:ext cx="0" cy="594360"/>
+          </a:xfrm>
+          <a:prstGeom prst="line">
+            <a:avLst/>
+          </a:prstGeom>
+          <a:noFill/>
+          <a:ln w="25400">
+            <a:solidFill>
+              <a:srgbClr val="8A8A8A"/>
+            </a:solidFill>
+            <a:prstDash val="solid"/>
+          </a:ln>
+        </p:spPr>
+      </p:sp>
+      <p:sp>
+        <p:nvSpPr>
+          <p:cNvPr id="4" name="Shape 2"/>
+          <p:cNvSpPr/>
+          <p:nvPr/>
+        </p:nvSpPr>
+        <p:spPr>
+          <a:xfrm>
+            <a:off x="9836912" y="5132832"/>
+            <a:ext cx="0" cy="594360"/>
+          </a:xfrm>
+          <a:prstGeom prst="line">
+            <a:avLst/>
+          </a:prstGeom>
+          <a:noFill/>
+          <a:ln w="25400">
+            <a:solidFill>
+              <a:srgbClr val="8A8A8A"/>
+            </a:solidFill>
+            <a:prstDash val="solid"/>
+          </a:ln>
+        </p:spPr>
+      </p:sp>
+      <p:sp>
+        <p:nvSpPr>
+          <p:cNvPr id="5" name="Text 3"/>
+          <p:cNvSpPr txBox="1"/>
+          <p:nvPr/>
+        </p:nvSpPr>
+        <p:spPr>
+          <a:xfrm>
+            <a:off x="9935972" y="5109972"/>
+            <a:ext cx="1097280" cy="640080"/>
+          </a:xfrm>
+          <a:prstGeom prst="rect">
+            <a:avLst/>
+          </a:prstGeom>
+          <a:noFill/>
+          <a:ln/>
+        </p:spPr>
+        <p:txBody>
+          <a:bodyPr wrap="square" lIns="0" tIns="0" rIns="0" bIns="0" rtlCol="0" anchor="ctr"/>
+          <a:lstStyle/>
+          <a:p>
+            <a:pPr algn="l" indent="0" marL="0">
+              <a:buNone/>
+            </a:pPr>
+            <a:r>
+              <a:rPr lang="en-US" sz="3600" b="1" dirty="0">
+                <a:solidFill>
+                  <a:srgbClr val="BBBBBB"/>
+                </a:solidFill>
+                <a:latin typeface="Arial" pitchFamily="34" charset="0"/>
+                <a:ea typeface="Arial" pitchFamily="34" charset="-122"/>
+                <a:cs typeface="Arial" pitchFamily="34" charset="-120"/>
+              </a:rPr>
+              <a:t>×2</a:t>
+            </a:r>
+            <a:endParaRPr lang="en-US" sz="3600" dirty="0"/>
           </a:p>
         </p:txBody>
       </p:sp>
@@ -1898,6 +2207,9 @@
           <a:lstStyle/>
           <a:p>
             <a:pPr algn="ctr" indent="0" marL="0">
+              <a:lnSpc>
+                <a:spcPts val="6200"/>
+              </a:lnSpc>
               <a:buNone/>
             </a:pPr>
             <a:r>
@@ -1915,6 +2227,9 @@
           </a:p>
           <a:p>
             <a:pPr algn="ctr" indent="0" marL="0">
+              <a:lnSpc>
+                <a:spcPts val="6200"/>
+              </a:lnSpc>
               <a:buNone/>
             </a:pPr>
             <a:r>
@@ -1932,6 +2247,9 @@
           </a:p>
           <a:p>
             <a:pPr algn="ctr" indent="0" marL="0">
+              <a:lnSpc>
+                <a:spcPts val="6200"/>
+              </a:lnSpc>
               <a:buNone/>
             </a:pPr>
             <a:r>
@@ -1949,6 +2267,9 @@
           </a:p>
           <a:p>
             <a:pPr algn="ctr" indent="0" marL="0">
+              <a:lnSpc>
+                <a:spcPts val="6200"/>
+              </a:lnSpc>
               <a:buNone/>
             </a:pPr>
             <a:r>
@@ -1966,6 +2287,9 @@
           </a:p>
           <a:p>
             <a:pPr algn="ctr" indent="0" marL="0">
+              <a:lnSpc>
+                <a:spcPts val="6200"/>
+              </a:lnSpc>
               <a:buNone/>
             </a:pPr>
             <a:r>
@@ -1983,6 +2307,9 @@
           </a:p>
           <a:p>
             <a:pPr algn="ctr" indent="0" marL="0">
+              <a:lnSpc>
+                <a:spcPts val="6200"/>
+              </a:lnSpc>
               <a:buNone/>
             </a:pPr>
             <a:r>
@@ -1994,7 +2321,7 @@
                 <a:ea typeface="Arial" pitchFamily="34" charset="-122"/>
                 <a:cs typeface="Arial" pitchFamily="34" charset="-120"/>
               </a:rPr>
-              <a:t>||: в сонцесяйний край дійти. :||</a:t>
+              <a:t>в сонцесяйний край дійти.</a:t>
             </a:r>
             <a:endParaRPr lang="en-US" sz="5200" dirty="0"/>
           </a:p>
@@ -2002,7 +2329,92 @@
       </p:sp>
       <p:sp>
         <p:nvSpPr>
-          <p:cNvPr id="3" name="Text 1"/>
+          <p:cNvPr id="3" name="Shape 1"/>
+          <p:cNvSpPr/>
+          <p:nvPr/>
+        </p:nvSpPr>
+        <p:spPr>
+          <a:xfrm>
+            <a:off x="1518514" y="5132832"/>
+            <a:ext cx="0" cy="594360"/>
+          </a:xfrm>
+          <a:prstGeom prst="line">
+            <a:avLst/>
+          </a:prstGeom>
+          <a:noFill/>
+          <a:ln w="25400">
+            <a:solidFill>
+              <a:srgbClr val="8A8A8A"/>
+            </a:solidFill>
+            <a:prstDash val="solid"/>
+          </a:ln>
+        </p:spPr>
+      </p:sp>
+      <p:sp>
+        <p:nvSpPr>
+          <p:cNvPr id="4" name="Shape 2"/>
+          <p:cNvSpPr/>
+          <p:nvPr/>
+        </p:nvSpPr>
+        <p:spPr>
+          <a:xfrm>
+            <a:off x="10679582" y="5132832"/>
+            <a:ext cx="0" cy="594360"/>
+          </a:xfrm>
+          <a:prstGeom prst="line">
+            <a:avLst/>
+          </a:prstGeom>
+          <a:noFill/>
+          <a:ln w="25400">
+            <a:solidFill>
+              <a:srgbClr val="8A8A8A"/>
+            </a:solidFill>
+            <a:prstDash val="solid"/>
+          </a:ln>
+        </p:spPr>
+      </p:sp>
+      <p:sp>
+        <p:nvSpPr>
+          <p:cNvPr id="5" name="Text 3"/>
+          <p:cNvSpPr txBox="1"/>
+          <p:nvPr/>
+        </p:nvSpPr>
+        <p:spPr>
+          <a:xfrm>
+            <a:off x="10778642" y="5109972"/>
+            <a:ext cx="1097280" cy="640080"/>
+          </a:xfrm>
+          <a:prstGeom prst="rect">
+            <a:avLst/>
+          </a:prstGeom>
+          <a:noFill/>
+          <a:ln/>
+        </p:spPr>
+        <p:txBody>
+          <a:bodyPr wrap="square" lIns="0" tIns="0" rIns="0" bIns="0" rtlCol="0" anchor="ctr"/>
+          <a:lstStyle/>
+          <a:p>
+            <a:pPr algn="l" indent="0" marL="0">
+              <a:buNone/>
+            </a:pPr>
+            <a:r>
+              <a:rPr lang="en-US" sz="3600" b="1" dirty="0">
+                <a:solidFill>
+                  <a:srgbClr val="BBBBBB"/>
+                </a:solidFill>
+                <a:latin typeface="Arial" pitchFamily="34" charset="0"/>
+                <a:ea typeface="Arial" pitchFamily="34" charset="-122"/>
+                <a:cs typeface="Arial" pitchFamily="34" charset="-120"/>
+              </a:rPr>
+              <a:t>×2</a:t>
+            </a:r>
+            <a:endParaRPr lang="en-US" sz="3600" dirty="0"/>
+          </a:p>
+        </p:txBody>
+      </p:sp>
+      <p:sp>
+        <p:nvSpPr>
+          <p:cNvPr id="6" name="Text 4"/>
           <p:cNvSpPr txBox="1"/>
           <p:nvPr/>
         </p:nvSpPr>

</xml_diff>